<commit_message>
Read the scoreboard and the headline from the shared testbench
A collaborator ran both models through common/backtest.py, so reports/testbench.json
now carries terrain-parametric and sionna-hybrid-agronomy on identical splits. The
deck reads it rather than carrying typed figures: the scoreboard fills the rows that
exist and dashes the rest, and the title slide's headline is whichever simulator
currently holds the best held-out score rather than a hardcoded number that goes
stale the moment an approach improves.

On those splits the Sionna hybrid takes KMeans blocks from 9.59 to 7.95 dB and
angular wedges from 9.81 to 7.80.
</commit_message>
<xml_diff>
--- a/ARA_Challenge3.pptx
+++ b/ARA_Challenge3.pptx
@@ -4536,7 +4536,7 @@
                 </a:solidFill>
                 <a:latin typeface="Consolas"/>
               </a:rPr>
-              <a:t>HELD-OUT ACCURACY</a:t>
+              <a:t>BEST HELD-OUT</a:t>
             </a:r>
           </a:p>
         </p:txBody>
@@ -4571,7 +4571,7 @@
                 </a:solidFill>
                 <a:latin typeface="Archivo"/>
               </a:rPr>
-              <a:t>9.66 dB</a:t>
+              <a:t>7.95 dB</a:t>
             </a:r>
           </a:p>
         </p:txBody>
@@ -4606,7 +4606,7 @@
                 </a:solidFill>
                 <a:latin typeface="Consolas"/>
               </a:rPr>
-              <a:t>RMSE, geographic blocks</a:t>
+              <a:t>KMeans blocks · sionna-hybrid-agronomy</a:t>
             </a:r>
           </a:p>
         </p:txBody>
@@ -6415,7 +6415,7 @@
                           </a:solidFill>
                           <a:latin typeface="Consolas"/>
                         </a:rPr>
-                        <a:t>9.66</a:t>
+                        <a:t>9.59</a:t>
                       </a:r>
                     </a:p>
                   </a:txBody>
@@ -6438,7 +6438,7 @@
                           </a:solidFill>
                           <a:latin typeface="Consolas"/>
                         </a:rPr>
-                        <a:t>9.78</a:t>
+                        <a:t>9.81</a:t>
                       </a:r>
                     </a:p>
                   </a:txBody>
@@ -6485,7 +6485,7 @@
                           </a:solidFill>
                           <a:latin typeface="Consolas"/>
                         </a:rPr>
-                        <a:t>Sionna ray tracing</a:t>
+                        <a:t>Sionna ray tracing (hybrid)</a:t>
                       </a:r>
                     </a:p>
                   </a:txBody>
@@ -6508,7 +6508,7 @@
                           </a:solidFill>
                           <a:latin typeface="Consolas"/>
                         </a:rPr>
-                        <a:t>—</a:t>
+                        <a:t>7.61</a:t>
                       </a:r>
                     </a:p>
                   </a:txBody>
@@ -6531,7 +6531,7 @@
                           </a:solidFill>
                           <a:latin typeface="Consolas"/>
                         </a:rPr>
-                        <a:t>—</a:t>
+                        <a:t>7.59</a:t>
                       </a:r>
                     </a:p>
                   </a:txBody>
@@ -6554,7 +6554,7 @@
                           </a:solidFill>
                           <a:latin typeface="Consolas"/>
                         </a:rPr>
-                        <a:t>8.29</a:t>
+                        <a:t>7.95</a:t>
                       </a:r>
                     </a:p>
                   </a:txBody>
@@ -6577,7 +6577,7 @@
                           </a:solidFill>
                           <a:latin typeface="Consolas"/>
                         </a:rPr>
-                        <a:t>—</a:t>
+                        <a:t>7.80</a:t>
                       </a:r>
                     </a:p>
                   </a:txBody>
@@ -6600,7 +6600,7 @@
                           </a:solidFill>
                           <a:latin typeface="Consolas"/>
                         </a:rPr>
-                        <a:t>no — nothing fitted</a:t>
+                        <a:t>yes</a:t>
                       </a:r>
                     </a:p>
                   </a:txBody>
@@ -6624,7 +6624,7 @@
                           </a:solidFill>
                           <a:latin typeface="Consolas"/>
                         </a:rPr>
-                        <a:t>FNO on profiles</a:t>
+                        <a:t>FNO on path profiles</a:t>
                       </a:r>
                     </a:p>
                   </a:txBody>
@@ -6739,7 +6739,7 @@
                           </a:solidFill>
                           <a:latin typeface="Consolas"/>
                         </a:rPr>
-                        <a:t>yes</a:t>
+                        <a:t>not yet run</a:t>
                       </a:r>
                     </a:p>
                   </a:txBody>
@@ -6878,7 +6878,7 @@
                           </a:solidFill>
                           <a:latin typeface="Consolas"/>
                         </a:rPr>
-                        <a:t>—</a:t>
+                        <a:t>reserved</a:t>
                       </a:r>
                     </a:p>
                   </a:txBody>
@@ -6923,7 +6923,7 @@
                 </a:solidFill>
                 <a:latin typeface="Consolas"/>
               </a:rPr>
-              <a:t>Blank cells are work not yet done, not results withheld. The table is completed when every simulator has run — the numbers above are produced by python -m common.selftest, which fails if the bench itself has changed.</a:t>
+              <a:t>Dashes are work not yet done, not results withheld. Produced by one harness from reports/testbench.json — and python -m common.selftest reproduces the published reference to 0.02 dB, so a change to the bench is caught rather than absorbed into the numbers.</a:t>
             </a:r>
           </a:p>
         </p:txBody>

</xml_diff>

<commit_message>
Rebuild the planner page on the merged template
Picks up the marginal-gain fix from 986f220: solve() already stores each round's
gain over everything placed before it, so the table was differencing an already-
differenced number and showing rounds 2 and 3 as negative. The built page carried
the old code until now.

Also rebuilds the deck: slide 9 leads with what the neural operator is rather than
a methodology tour, and the scoreboard reads reports/testbench.json so rows fill
themselves as simulators land.
</commit_message>
<xml_diff>
--- a/ARA_Challenge3.pptx
+++ b/ARA_Challenge3.pptx
@@ -6624,7 +6624,7 @@
                           </a:solidFill>
                           <a:latin typeface="Consolas"/>
                         </a:rPr>
-                        <a:t>FNO on path profiles</a:t>
+                        <a:t>Neural operator (FNO)</a:t>
                       </a:r>
                     </a:p>
                   </a:txBody>
@@ -17676,7 +17676,7 @@
                 </a:solidFill>
                 <a:latin typeface="Archivo"/>
               </a:rPr>
-              <a:t>Neural operator — a 1-D FNO over path profiles</a:t>
+              <a:t>Neural operator — a learned map from terrain profile to signal</a:t>
             </a:r>
           </a:p>
         </p:txBody>
@@ -17711,7 +17711,7 @@
                 </a:solidFill>
                 <a:latin typeface="Archivo"/>
               </a:rPr>
-              <a:t>The framing is the whole difficulty. Most of the operator family cannot be posed on this dataset at all.</a:t>
+              <a:t>A 1-D Fourier neural operator. It does not trace rays and it does not assume a path-loss law; it learns the terrain term directly from 3,838 measured links.</a:t>
             </a:r>
           </a:p>
         </p:txBody>
@@ -17751,519 +17751,16 @@
           </a:p>
         </p:txBody>
       </p:sp>
-      <p:graphicFrame>
-        <p:nvGraphicFramePr>
-          <p:cNvPr id="9" name="Table 8"/>
-          <p:cNvGraphicFramePr>
-            <a:graphicFrameLocks noGrp="1"/>
-          </p:cNvGraphicFramePr>
-          <p:nvPr/>
-        </p:nvGraphicFramePr>
-        <p:xfrm>
-          <a:off x="502920" y="1737360"/>
-          <a:ext cx="5943599" cy="2103120"/>
-        </p:xfrm>
-        <a:graphic>
-          <a:graphicData uri="http://schemas.openxmlformats.org/drawingml/2006/table">
-            <a:tbl>
-              <a:tblPr firstRow="1" bandRow="1">
-                <a:tableStyleId>{5C22544A-7EE6-4342-B048-85BDC9FD1C3A}</a:tableStyleId>
-              </a:tblPr>
-              <a:tblGrid>
-                <a:gridCol w="2194560"/>
-                <a:gridCol w="3749039"/>
-              </a:tblGrid>
-              <a:tr h="350520">
-                <a:tc>
-                  <a:txBody>
-                    <a:bodyPr/>
-                    <a:lstStyle/>
-                    <a:p>
-                      <a:r>
-                        <a:rPr sz="900" b="1">
-                          <a:solidFill>
-                            <a:srgbClr val="65726B"/>
-                          </a:solidFill>
-                          <a:latin typeface="Consolas"/>
-                        </a:rPr>
-                        <a:t>model</a:t>
-                      </a:r>
-                    </a:p>
-                  </a:txBody>
-                  <a:tcPr marL="54864" marR="54864" marT="27432" marB="27432">
-                    <a:solidFill>
-                      <a:srgbClr val="F1F4EF"/>
-                    </a:solidFill>
-                  </a:tcPr>
-                </a:tc>
-                <a:tc>
-                  <a:txBody>
-                    <a:bodyPr/>
-                    <a:lstStyle/>
-                    <a:p>
-                      <a:pPr algn="r"/>
-                      <a:r>
-                        <a:rPr sz="900" b="1">
-                          <a:solidFill>
-                            <a:srgbClr val="65726B"/>
-                          </a:solidFill>
-                          <a:latin typeface="Consolas"/>
-                        </a:rPr>
-                        <a:t>verdict on this dataset</a:t>
-                      </a:r>
-                    </a:p>
-                  </a:txBody>
-                  <a:tcPr marL="54864" marR="54864" marT="27432" marB="27432">
-                    <a:solidFill>
-                      <a:srgbClr val="F1F4EF"/>
-                    </a:solidFill>
-                  </a:tcPr>
-                </a:tc>
-              </a:tr>
-              <a:tr h="350520">
-                <a:tc>
-                  <a:txBody>
-                    <a:bodyPr/>
-                    <a:lstStyle/>
-                    <a:p>
-                      <a:r>
-                        <a:rPr sz="900" b="0">
-                          <a:solidFill>
-                            <a:srgbClr val="16211C"/>
-                          </a:solidFill>
-                          <a:latin typeface="Consolas"/>
-                        </a:rPr>
-                        <a:t>FNO / TFNO / UNO / WNO in 2-D</a:t>
-                      </a:r>
-                    </a:p>
-                  </a:txBody>
-                  <a:tcPr marL="54864" marR="54864" marT="27432" marB="27432">
-                    <a:solidFill>
-                      <a:srgbClr val="FFFFFF"/>
-                    </a:solidFill>
-                  </a:tcPr>
-                </a:tc>
-                <a:tc>
-                  <a:txBody>
-                    <a:bodyPr/>
-                    <a:lstStyle/>
-                    <a:p>
-                      <a:pPr algn="r"/>
-                      <a:r>
-                        <a:rPr sz="900" b="0">
-                          <a:solidFill>
-                            <a:srgbClr val="16211C"/>
-                          </a:solidFill>
-                          <a:latin typeface="Consolas"/>
-                        </a:rPr>
-                        <a:t>(terrain, TX) → surface has ONE training example. Not viable.</a:t>
-                      </a:r>
-                    </a:p>
-                  </a:txBody>
-                  <a:tcPr marL="54864" marR="54864" marT="27432" marB="27432">
-                    <a:solidFill>
-                      <a:srgbClr val="FFFFFF"/>
-                    </a:solidFill>
-                  </a:tcPr>
-                </a:tc>
-              </a:tr>
-              <a:tr h="350520">
-                <a:tc>
-                  <a:txBody>
-                    <a:bodyPr/>
-                    <a:lstStyle/>
-                    <a:p>
-                      <a:r>
-                        <a:rPr sz="900" b="0">
-                          <a:solidFill>
-                            <a:srgbClr val="16211C"/>
-                          </a:solidFill>
-                          <a:latin typeface="Consolas"/>
-                        </a:rPr>
-                        <a:t>NeRF2</a:t>
-                      </a:r>
-                    </a:p>
-                  </a:txBody>
-                  <a:tcPr marL="54864" marR="54864" marT="27432" marB="27432">
-                    <a:solidFill>
-                      <a:srgbClr val="FFFFFF"/>
-                    </a:solidFill>
-                  </a:tcPr>
-                </a:tc>
-                <a:tc>
-                  <a:txBody>
-                    <a:bodyPr/>
-                    <a:lstStyle/>
-                    <a:p>
-                      <a:pPr algn="r"/>
-                      <a:r>
-                        <a:rPr sz="900" b="0">
-                          <a:solidFill>
-                            <a:srgbClr val="16211C"/>
-                          </a:solidFill>
-                          <a:latin typeface="Consolas"/>
-                        </a:rPr>
-                        <a:t>needs many TX or dense volumetric RX. One TX, road-confined.</a:t>
-                      </a:r>
-                    </a:p>
-                  </a:txBody>
-                  <a:tcPr marL="54864" marR="54864" marT="27432" marB="27432">
-                    <a:solidFill>
-                      <a:srgbClr val="FFFFFF"/>
-                    </a:solidFill>
-                  </a:tcPr>
-                </a:tc>
-              </a:tr>
-              <a:tr h="350520">
-                <a:tc>
-                  <a:txBody>
-                    <a:bodyPr/>
-                    <a:lstStyle/>
-                    <a:p>
-                      <a:r>
-                        <a:rPr sz="900" b="0">
-                          <a:solidFill>
-                            <a:srgbClr val="16211C"/>
-                          </a:solidFill>
-                          <a:latin typeface="Consolas"/>
-                        </a:rPr>
-                        <a:t>SFNO</a:t>
-                      </a:r>
-                    </a:p>
-                  </a:txBody>
-                  <a:tcPr marL="54864" marR="54864" marT="27432" marB="27432">
-                    <a:solidFill>
-                      <a:srgbClr val="FFFFFF"/>
-                    </a:solidFill>
-                  </a:tcPr>
-                </a:tc>
-                <a:tc>
-                  <a:txBody>
-                    <a:bodyPr/>
-                    <a:lstStyle/>
-                    <a:p>
-                      <a:pPr algn="r"/>
-                      <a:r>
-                        <a:rPr sz="900" b="0">
-                          <a:solidFill>
-                            <a:srgbClr val="16211C"/>
-                          </a:solidFill>
-                          <a:latin typeface="Consolas"/>
-                        </a:rPr>
-                        <a:t>spherical harmonics; the box is 11 × 16 km.</a:t>
-                      </a:r>
-                    </a:p>
-                  </a:txBody>
-                  <a:tcPr marL="54864" marR="54864" marT="27432" marB="27432">
-                    <a:solidFill>
-                      <a:srgbClr val="FFFFFF"/>
-                    </a:solidFill>
-                  </a:tcPr>
-                </a:tc>
-              </a:tr>
-              <a:tr h="350520">
-                <a:tc>
-                  <a:txBody>
-                    <a:bodyPr/>
-                    <a:lstStyle/>
-                    <a:p>
-                      <a:r>
-                        <a:rPr sz="900" b="0">
-                          <a:solidFill>
-                            <a:srgbClr val="16211C"/>
-                          </a:solidFill>
-                          <a:latin typeface="Consolas"/>
-                        </a:rPr>
-                        <a:t>CoDANO</a:t>
-                      </a:r>
-                    </a:p>
-                  </a:txBody>
-                  <a:tcPr marL="54864" marR="54864" marT="27432" marB="27432">
-                    <a:solidFill>
-                      <a:srgbClr val="FFFFFF"/>
-                    </a:solidFill>
-                  </a:tcPr>
-                </a:tc>
-                <a:tc>
-                  <a:txBody>
-                    <a:bodyPr/>
-                    <a:lstStyle/>
-                    <a:p>
-                      <a:pPr algn="r"/>
-                      <a:r>
-                        <a:rPr sz="900" b="0">
-                          <a:solidFill>
-                            <a:srgbClr val="16211C"/>
-                          </a:solidFill>
-                          <a:latin typeface="Consolas"/>
-                        </a:rPr>
-                        <a:t>codomain attention across coupled variables; there is one.</a:t>
-                      </a:r>
-                    </a:p>
-                  </a:txBody>
-                  <a:tcPr marL="54864" marR="54864" marT="27432" marB="27432">
-                    <a:solidFill>
-                      <a:srgbClr val="FFFFFF"/>
-                    </a:solidFill>
-                  </a:tcPr>
-                </a:tc>
-              </a:tr>
-              <a:tr h="350520">
-                <a:tc>
-                  <a:txBody>
-                    <a:bodyPr/>
-                    <a:lstStyle/>
-                    <a:p>
-                      <a:r>
-                        <a:rPr sz="900" b="0">
-                          <a:solidFill>
-                            <a:srgbClr val="16211C"/>
-                          </a:solidFill>
-                          <a:latin typeface="Consolas"/>
-                        </a:rPr>
-                        <a:t>GeNeRT</a:t>
-                      </a:r>
-                    </a:p>
-                  </a:txBody>
-                  <a:tcPr marL="54864" marR="54864" marT="27432" marB="27432">
-                    <a:solidFill>
-                      <a:srgbClr val="FFFFFF"/>
-                    </a:solidFill>
-                  </a:tcPr>
-                </a:tc>
-                <a:tc>
-                  <a:txBody>
-                    <a:bodyPr/>
-                    <a:lstStyle/>
-                    <a:p>
-                      <a:pPr algn="r"/>
-                      <a:r>
-                        <a:rPr sz="900" b="0">
-                          <a:solidFill>
-                            <a:srgbClr val="16211C"/>
-                          </a:solidFill>
-                          <a:latin typeface="Consolas"/>
-                        </a:rPr>
-                        <a:t>needs a semantic 3-D scene and ray-traced CIRs; no weights.</a:t>
-                      </a:r>
-                    </a:p>
-                  </a:txBody>
-                  <a:tcPr marL="54864" marR="54864" marT="27432" marB="27432">
-                    <a:solidFill>
-                      <a:srgbClr val="FFFFFF"/>
-                    </a:solidFill>
-                  </a:tcPr>
-                </a:tc>
-              </a:tr>
-            </a:tbl>
-          </a:graphicData>
-        </a:graphic>
-      </p:graphicFrame>
-      <p:sp>
-        <p:nvSpPr>
-          <p:cNvPr id="10" name="TextBox 9"/>
-          <p:cNvSpPr txBox="1"/>
-          <p:nvPr/>
-        </p:nvSpPr>
-        <p:spPr>
-          <a:xfrm>
-            <a:off x="502920" y="3977639"/>
-            <a:ext cx="5943600" cy="274320"/>
-          </a:xfrm>
-          <a:prstGeom prst="rect">
-            <a:avLst/>
-          </a:prstGeom>
-          <a:noFill/>
-        </p:spPr>
-        <p:txBody>
-          <a:bodyPr wrap="square" anchor="t" lIns="0" rIns="0" tIns="0" bIns="0">
-            <a:spAutoFit/>
-          </a:bodyPr>
-          <a:lstStyle/>
-          <a:p>
-            <a:pPr algn="l"/>
-            <a:r>
-              <a:rPr sz="1100" b="1" spc="120">
-                <a:solidFill>
-                  <a:srgbClr val="5B3A9B"/>
-                </a:solidFill>
-                <a:latin typeface="Consolas"/>
-              </a:rPr>
-              <a:t>THE FRAMING THAT IS WELL POSED</a:t>
-            </a:r>
-          </a:p>
-        </p:txBody>
-      </p:sp>
-      <p:sp>
-        <p:nvSpPr>
-          <p:cNvPr id="11" name="TextBox 10"/>
-          <p:cNvSpPr txBox="1"/>
-          <p:nvPr/>
-        </p:nvSpPr>
-        <p:spPr>
-          <a:xfrm>
-            <a:off x="502920" y="4279392"/>
-            <a:ext cx="5943600" cy="914400"/>
-          </a:xfrm>
-          <a:prstGeom prst="rect">
-            <a:avLst/>
-          </a:prstGeom>
-          <a:noFill/>
-        </p:spPr>
-        <p:txBody>
-          <a:bodyPr wrap="square" anchor="t" lIns="0" rIns="0" tIns="0" bIns="0">
-            <a:spAutoFit/>
-          </a:bodyPr>
-          <a:lstStyle/>
-          <a:p>
-            <a:pPr algn="l"/>
-            <a:r>
-              <a:rPr sz="1200" b="0">
-                <a:solidFill>
-                  <a:srgbClr val="3A4842"/>
-                </a:solidFill>
-                <a:latin typeface="Archivo"/>
-              </a:rPr>
-              <a:t>Stop treating the area as the function. The terrain profile along each link is a genuine input function on [0,1] — 3,838 of them — and it competes head-to-head with the P.526 term it would replace.</a:t>
-            </a:r>
-          </a:p>
-        </p:txBody>
-      </p:sp>
-      <p:sp>
-        <p:nvSpPr>
-          <p:cNvPr id="12" name="Rectangle 11"/>
-          <p:cNvSpPr/>
-          <p:nvPr/>
-        </p:nvSpPr>
-        <p:spPr>
-          <a:xfrm>
-            <a:off x="6720840" y="1737360"/>
-            <a:ext cx="4937760" cy="2148840"/>
-          </a:xfrm>
-          <a:prstGeom prst="rect">
-            <a:avLst/>
-          </a:prstGeom>
-          <a:solidFill>
-            <a:srgbClr val="F1F4EF"/>
-          </a:solidFill>
-          <a:ln w="19050">
-            <a:solidFill>
-              <a:srgbClr val="8C1D40"/>
-            </a:solidFill>
-          </a:ln>
-          <a:effectLst/>
-        </p:spPr>
-        <p:style>
-          <a:lnRef idx="1">
-            <a:schemeClr val="accent1"/>
-          </a:lnRef>
-          <a:fillRef idx="3">
-            <a:schemeClr val="accent1"/>
-          </a:fillRef>
-          <a:effectRef idx="2">
-            <a:schemeClr val="accent1"/>
-          </a:effectRef>
-          <a:fontRef idx="minor">
-            <a:schemeClr val="lt1"/>
-          </a:fontRef>
-        </p:style>
-        <p:txBody>
-          <a:bodyPr rtlCol="0" anchor="ctr"/>
-          <a:lstStyle/>
-          <a:p>
-            <a:pPr algn="ctr"/>
-          </a:p>
-        </p:txBody>
-      </p:sp>
-      <p:sp>
-        <p:nvSpPr>
-          <p:cNvPr id="13" name="Rectangle 12"/>
-          <p:cNvSpPr/>
-          <p:nvPr/>
-        </p:nvSpPr>
-        <p:spPr>
-          <a:xfrm>
-            <a:off x="6720840" y="1737360"/>
-            <a:ext cx="54864" cy="2148840"/>
-          </a:xfrm>
-          <a:prstGeom prst="rect">
-            <a:avLst/>
-          </a:prstGeom>
-          <a:solidFill>
-            <a:srgbClr val="8C1D40"/>
-          </a:solidFill>
-          <a:ln>
-            <a:noFill/>
-          </a:ln>
-          <a:effectLst/>
-        </p:spPr>
-        <p:style>
-          <a:lnRef idx="1">
-            <a:schemeClr val="accent1"/>
-          </a:lnRef>
-          <a:fillRef idx="3">
-            <a:schemeClr val="accent1"/>
-          </a:fillRef>
-          <a:effectRef idx="2">
-            <a:schemeClr val="accent1"/>
-          </a:effectRef>
-          <a:fontRef idx="minor">
-            <a:schemeClr val="lt1"/>
-          </a:fontRef>
-        </p:style>
-        <p:txBody>
-          <a:bodyPr rtlCol="0" anchor="ctr"/>
-          <a:lstStyle/>
-          <a:p>
-            <a:pPr algn="ctr"/>
-          </a:p>
-        </p:txBody>
-      </p:sp>
-      <p:sp>
-        <p:nvSpPr>
-          <p:cNvPr id="14" name="TextBox 13"/>
-          <p:cNvSpPr txBox="1"/>
-          <p:nvPr/>
-        </p:nvSpPr>
-        <p:spPr>
-          <a:xfrm>
-            <a:off x="6949440" y="1874519"/>
-            <a:ext cx="4572000" cy="274320"/>
-          </a:xfrm>
-          <a:prstGeom prst="rect">
-            <a:avLst/>
-          </a:prstGeom>
-          <a:noFill/>
-        </p:spPr>
-        <p:txBody>
-          <a:bodyPr wrap="square" anchor="t" lIns="0" rIns="0" tIns="0" bIns="0">
-            <a:spAutoFit/>
-          </a:bodyPr>
-          <a:lstStyle/>
-          <a:p>
-            <a:pPr algn="l"/>
-            <a:r>
-              <a:rPr sz="1250" b="1">
-                <a:solidFill>
-                  <a:srgbClr val="8C1D40"/>
-                </a:solidFill>
-                <a:latin typeface="Archivo"/>
-              </a:rPr>
-              <a:t>A terrain profile is a location fingerprint</a:t>
-            </a:r>
-          </a:p>
-        </p:txBody>
-      </p:sp>
-      <p:sp>
-        <p:nvSpPr>
-          <p:cNvPr id="15" name="TextBox 14"/>
-          <p:cNvSpPr txBox="1"/>
-          <p:nvPr/>
-        </p:nvSpPr>
-        <p:spPr>
-          <a:xfrm>
-            <a:off x="6949440" y="2240280"/>
-            <a:ext cx="4572000" cy="1554480"/>
+      <p:sp>
+        <p:nvSpPr>
+          <p:cNvPr id="9" name="TextBox 8"/>
+          <p:cNvSpPr txBox="1"/>
+          <p:nvPr/>
+        </p:nvSpPr>
+        <p:spPr>
+          <a:xfrm>
+            <a:off x="502920" y="1783080"/>
+            <a:ext cx="5486400" cy="2194560"/>
           </a:xfrm>
           <a:prstGeom prst="rect">
             <a:avLst/>
@@ -18282,13 +17779,13 @@
               </a:spcAft>
             </a:pPr>
             <a:r>
-              <a:rPr sz="1000" b="0">
-                <a:solidFill>
-                  <a:srgbClr val="3A4842"/>
+              <a:rPr sz="1100" b="1">
+                <a:solidFill>
+                  <a:srgbClr val="16211C"/>
                 </a:solidFill>
                 <a:latin typeface="Archivo"/>
               </a:rPr>
-              <a:t>— Nearest other link in profile space: median 12.2 m away on the ground.</a:t>
+              <a:t>— The input is a function, not a number.</a:t>
             </a:r>
           </a:p>
           <a:p>
@@ -18298,13 +17795,13 @@
               </a:spcAft>
             </a:pPr>
             <a:r>
-              <a:rPr sz="1000" b="0">
+              <a:rPr sz="1100" b="0">
                 <a:solidFill>
                   <a:srgbClr val="3A4842"/>
                 </a:solidFill>
                 <a:latin typeface="Archivo"/>
               </a:rPr>
-              <a:t>— 97.2% within 50 m; 99.6% within 200 m.</a:t>
+              <a:t>— For every link, ground elevation is sampled at 128 points along the path from the tower to the receiver. That profile is the input; the received power is the output.</a:t>
             </a:r>
           </a:p>
           <a:p>
@@ -18314,27 +17811,43 @@
               </a:spcAft>
             </a:pPr>
             <a:r>
-              <a:rPr sz="1000" b="1">
+              <a:rPr sz="1100" b="1">
                 <a:solidFill>
                   <a:srgbClr val="16211C"/>
                 </a:solidFill>
                 <a:latin typeface="Archivo"/>
               </a:rPr>
-              <a:t>— So on a random split a profile-fed network answers by looking up its own training set.</a:t>
-            </a:r>
-          </a:p>
-        </p:txBody>
-      </p:sp>
-      <p:sp>
-        <p:nvSpPr>
-          <p:cNvPr id="16" name="Rectangle 15"/>
+              <a:t>— It replaces the textbook diffraction term, not the whole model.</a:t>
+            </a:r>
+          </a:p>
+          <a:p>
+            <a:pPr>
+              <a:spcAft>
+                <a:spcPts val="600"/>
+              </a:spcAft>
+            </a:pPr>
+            <a:r>
+              <a:rPr sz="1100" b="0">
+                <a:solidFill>
+                  <a:srgbClr val="3A4842"/>
+                </a:solidFill>
+                <a:latin typeface="Archivo"/>
+              </a:rPr>
+              <a:t>— Distance and bearing stay parametric. The operator is asked only what the terrain along the path does to the signal — the same question ITU-R P.526 answers with a single knife edge.</a:t>
+            </a:r>
+          </a:p>
+        </p:txBody>
+      </p:sp>
+      <p:sp>
+        <p:nvSpPr>
+          <p:cNvPr id="10" name="Rectangle 9"/>
           <p:cNvSpPr/>
           <p:nvPr/>
         </p:nvSpPr>
         <p:spPr>
           <a:xfrm>
-            <a:off x="6720840" y="4023360"/>
-            <a:ext cx="4937760" cy="1920240"/>
+            <a:off x="6309360" y="1783080"/>
+            <a:ext cx="5394960" cy="2377440"/>
           </a:xfrm>
           <a:prstGeom prst="rect">
             <a:avLst/>
@@ -18373,14 +17886,14 @@
       </p:sp>
       <p:sp>
         <p:nvSpPr>
-          <p:cNvPr id="17" name="TextBox 16"/>
-          <p:cNvSpPr txBox="1"/>
-          <p:nvPr/>
-        </p:nvSpPr>
-        <p:spPr>
-          <a:xfrm>
-            <a:off x="6949440" y="4206240"/>
-            <a:ext cx="4572000" cy="274320"/>
+          <p:cNvPr id="11" name="TextBox 10"/>
+          <p:cNvSpPr txBox="1"/>
+          <p:nvPr/>
+        </p:nvSpPr>
+        <p:spPr>
+          <a:xfrm>
+            <a:off x="6537960" y="1965960"/>
+            <a:ext cx="4937760" cy="274320"/>
           </a:xfrm>
           <a:prstGeom prst="rect">
             <a:avLst/>
@@ -18401,21 +17914,21 @@
                 </a:solidFill>
                 <a:latin typeface="Archivo"/>
               </a:rPr>
-              <a:t>Reserved — head-to-head result</a:t>
-            </a:r>
-          </a:p>
-        </p:txBody>
-      </p:sp>
-      <p:sp>
-        <p:nvSpPr>
-          <p:cNvPr id="18" name="TextBox 17"/>
-          <p:cNvSpPr txBox="1"/>
-          <p:nvPr/>
-        </p:nvSpPr>
-        <p:spPr>
-          <a:xfrm>
-            <a:off x="6949440" y="4553712"/>
-            <a:ext cx="4572000" cy="1280160"/>
+              <a:t>Reserved — backtest result</a:t>
+            </a:r>
+          </a:p>
+        </p:txBody>
+      </p:sp>
+      <p:sp>
+        <p:nvSpPr>
+          <p:cNvPr id="12" name="TextBox 11"/>
+          <p:cNvSpPr txBox="1"/>
+          <p:nvPr/>
+        </p:nvSpPr>
+        <p:spPr>
+          <a:xfrm>
+            <a:off x="6537960" y="2331720"/>
+            <a:ext cx="4937760" cy="1645920"/>
           </a:xfrm>
           <a:prstGeom prst="rect">
             <a:avLst/>
@@ -18440,7 +17953,7 @@
                 </a:solidFill>
                 <a:latin typeface="Archivo"/>
               </a:rPr>
-              <a:t>— Same splits as every other model, imported not reimplemented.</a:t>
+              <a:t>— Runs on the shared testbench, so it lands straight into the scoreboard on slide 11.</a:t>
             </a:r>
           </a:p>
           <a:p>
@@ -18456,30 +17969,174 @@
                 </a:solidFill>
                 <a:latin typeface="Archivo"/>
               </a:rPr>
-              <a:t>— Controls: no-terrain backbone, ridge on 12 profile PCs, and the same network trained on shuffled profiles.</a:t>
-            </a:r>
-          </a:p>
-          <a:p>
-            <a:pPr>
-              <a:spcAft>
-                <a:spcPts val="600"/>
-              </a:spcAft>
-            </a:pPr>
-            <a:r>
-              <a:rPr sz="1000" b="0">
+              <a:t>— Same three splits, same 200 m buffer, same seed.</a:t>
+            </a:r>
+          </a:p>
+        </p:txBody>
+      </p:sp>
+      <p:sp>
+        <p:nvSpPr>
+          <p:cNvPr id="13" name="Rectangle 12"/>
+          <p:cNvSpPr/>
+          <p:nvPr/>
+        </p:nvSpPr>
+        <p:spPr>
+          <a:xfrm>
+            <a:off x="502920" y="4343400"/>
+            <a:ext cx="11155680" cy="1600200"/>
+          </a:xfrm>
+          <a:prstGeom prst="rect">
+            <a:avLst/>
+          </a:prstGeom>
+          <a:solidFill>
+            <a:srgbClr val="F1F4EF"/>
+          </a:solidFill>
+          <a:ln w="19050">
+            <a:solidFill>
+              <a:srgbClr val="5B3A9B"/>
+            </a:solidFill>
+          </a:ln>
+          <a:effectLst/>
+        </p:spPr>
+        <p:style>
+          <a:lnRef idx="1">
+            <a:schemeClr val="accent1"/>
+          </a:lnRef>
+          <a:fillRef idx="3">
+            <a:schemeClr val="accent1"/>
+          </a:fillRef>
+          <a:effectRef idx="2">
+            <a:schemeClr val="accent1"/>
+          </a:effectRef>
+          <a:fontRef idx="minor">
+            <a:schemeClr val="lt1"/>
+          </a:fontRef>
+        </p:style>
+        <p:txBody>
+          <a:bodyPr rtlCol="0" anchor="ctr"/>
+          <a:lstStyle/>
+          <a:p>
+            <a:pPr algn="ctr"/>
+          </a:p>
+        </p:txBody>
+      </p:sp>
+      <p:sp>
+        <p:nvSpPr>
+          <p:cNvPr id="14" name="Rectangle 13"/>
+          <p:cNvSpPr/>
+          <p:nvPr/>
+        </p:nvSpPr>
+        <p:spPr>
+          <a:xfrm>
+            <a:off x="502920" y="4343400"/>
+            <a:ext cx="54864" cy="1600200"/>
+          </a:xfrm>
+          <a:prstGeom prst="rect">
+            <a:avLst/>
+          </a:prstGeom>
+          <a:solidFill>
+            <a:srgbClr val="5B3A9B"/>
+          </a:solidFill>
+          <a:ln>
+            <a:noFill/>
+          </a:ln>
+          <a:effectLst/>
+        </p:spPr>
+        <p:style>
+          <a:lnRef idx="1">
+            <a:schemeClr val="accent1"/>
+          </a:lnRef>
+          <a:fillRef idx="3">
+            <a:schemeClr val="accent1"/>
+          </a:fillRef>
+          <a:effectRef idx="2">
+            <a:schemeClr val="accent1"/>
+          </a:effectRef>
+          <a:fontRef idx="minor">
+            <a:schemeClr val="lt1"/>
+          </a:fontRef>
+        </p:style>
+        <p:txBody>
+          <a:bodyPr rtlCol="0" anchor="ctr"/>
+          <a:lstStyle/>
+          <a:p>
+            <a:pPr algn="ctr"/>
+          </a:p>
+        </p:txBody>
+      </p:sp>
+      <p:sp>
+        <p:nvSpPr>
+          <p:cNvPr id="15" name="TextBox 14"/>
+          <p:cNvSpPr txBox="1"/>
+          <p:nvPr/>
+        </p:nvSpPr>
+        <p:spPr>
+          <a:xfrm>
+            <a:off x="777240" y="4498848"/>
+            <a:ext cx="10607040" cy="274320"/>
+          </a:xfrm>
+          <a:prstGeom prst="rect">
+            <a:avLst/>
+          </a:prstGeom>
+          <a:noFill/>
+        </p:spPr>
+        <p:txBody>
+          <a:bodyPr wrap="square" anchor="t" lIns="0" rIns="0" tIns="0" bIns="0">
+            <a:spAutoFit/>
+          </a:bodyPr>
+          <a:lstStyle/>
+          <a:p>
+            <a:pPr algn="l"/>
+            <a:r>
+              <a:rPr sz="1300" b="1">
+                <a:solidFill>
+                  <a:srgbClr val="5B3A9B"/>
+                </a:solidFill>
+                <a:latin typeface="Archivo"/>
+              </a:rPr>
+              <a:t>Why the split matters more here than anywhere else</a:t>
+            </a:r>
+          </a:p>
+        </p:txBody>
+      </p:sp>
+      <p:sp>
+        <p:nvSpPr>
+          <p:cNvPr id="16" name="TextBox 15"/>
+          <p:cNvSpPr txBox="1"/>
+          <p:nvPr/>
+        </p:nvSpPr>
+        <p:spPr>
+          <a:xfrm>
+            <a:off x="777240" y="4864608"/>
+            <a:ext cx="10607040" cy="914400"/>
+          </a:xfrm>
+          <a:prstGeom prst="rect">
+            <a:avLst/>
+          </a:prstGeom>
+          <a:noFill/>
+        </p:spPr>
+        <p:txBody>
+          <a:bodyPr wrap="square" anchor="t" lIns="0" rIns="0" tIns="0" bIns="0">
+            <a:spAutoFit/>
+          </a:bodyPr>
+          <a:lstStyle/>
+          <a:p>
+            <a:pPr algn="l"/>
+            <a:r>
+              <a:rPr sz="1200" b="0">
                 <a:solidFill>
                   <a:srgbClr val="3A4842"/>
                 </a:solidFill>
                 <a:latin typeface="Archivo"/>
               </a:rPr>
-              <a:t>— The control is what separates skill from the target distribution.</a:t>
-            </a:r>
-          </a:p>
-        </p:txBody>
-      </p:sp>
-      <p:sp>
-        <p:nvSpPr>
-          <p:cNvPr id="19" name="TextBox 18"/>
+              <a:t>A terrain profile is very nearly a unique identifier of where the receiver was: the nearest other link in profile space sits a median of 12.2 m away on the ground, and 97.2% are within 50 m. So on a random split this model can reach the answer by recognising the location rather than the physics. Only the geographic splits say anything about whether it has learned propagation.</a:t>
+            </a:r>
+          </a:p>
+        </p:txBody>
+      </p:sp>
+      <p:sp>
+        <p:nvSpPr>
+          <p:cNvPr id="17" name="TextBox 16"/>
           <p:cNvSpPr txBox="1"/>
           <p:nvPr/>
         </p:nvSpPr>
@@ -18507,7 +18164,7 @@
                 </a:solidFill>
                 <a:latin typeface="Consolas"/>
               </a:rPr>
-              <a:t>terrain-approach/NEURAL_OPERATOR.md   ·   torch 2.10 CPU · neuraloperator 2.0</a:t>
+              <a:t>terrain-approach/NEURAL_OPERATOR.md   ·   1-D FNO, 128-point profiles, torch CPU</a:t>
             </a:r>
           </a:p>
         </p:txBody>

</xml_diff>

<commit_message>
Actually remove the abstract closing line from slide 3
The previous commit claimed to replace it and did not. The replacement matched on
'18, INK, True, FH)' while the source said 'True, FD)', so str.replace found
nothing, changed nothing, and reported success -- and I read the success message
instead of the slide.

Every edit in that pass is now asserted before writing, which is what should have
caught it.

The line is gone. Slide 3 closes on 'All four fit the drive test. Only one still
works off it.' over the sentence that carries the numbers.

Co-Authored-By: Claude Opus 5 <noreply@anthropic.com>
</commit_message>
<xml_diff>
--- a/ARA_Challenge3.pptx
+++ b/ARA_Challenge3.pptx
@@ -5489,9 +5489,9 @@
                 <a:solidFill>
                   <a:srgbClr val="23201C"/>
                 </a:solidFill>
-                <a:latin typeface="Calibri"/>
+                <a:latin typeface="Cambria"/>
               </a:rPr>
-              <a:t>Same ground, four different bets about what matters</a:t>
+              <a:t>All four fit the drive test. Only one still works off it.</a:t>
             </a:r>
           </a:p>
         </p:txBody>

</xml_diff>

<commit_message>
Drop the summary band from slide 3 rather than rewriting it
The slide already carries four labelled figures with a line of explanation each.
A band underneath restating them was redundant however it was worded, which is
why two attempts at rewriting it both read as filler.

Removing it gives the figures the bottom of the slide: they go from 2.92in to
3.02in wide, the method names from 15pt to 17pt, and the descriptions from 15pt
to 15.5pt with room for a third line.

Slide 3 is now 45 words against 111.

Co-Authored-By: Claude Opus 5 <noreply@anthropic.com>
</commit_message>
<xml_diff>
--- a/ARA_Challenge3.pptx
+++ b/ARA_Challenge3.pptx
@@ -5049,8 +5049,8 @@
         </p:nvSpPr>
         <p:spPr>
           <a:xfrm>
-            <a:off x="475488" y="1664208"/>
-            <a:ext cx="2670048" cy="274320"/>
+            <a:off x="411480" y="1664208"/>
+            <a:ext cx="2761488" cy="274320"/>
           </a:xfrm>
           <a:prstGeom prst="rect">
             <a:avLst/>
@@ -5092,8 +5092,8 @@
         </p:blipFill>
         <p:spPr>
           <a:xfrm>
-            <a:off x="475488" y="2011680"/>
-            <a:ext cx="2670048" cy="2021608"/>
+            <a:off x="411480" y="2048256"/>
+            <a:ext cx="2761488" cy="2090841"/>
           </a:xfrm>
           <a:prstGeom prst="rect">
             <a:avLst/>
@@ -5108,8 +5108,8 @@
         </p:nvSpPr>
         <p:spPr>
           <a:xfrm>
-            <a:off x="475488" y="4078224"/>
-            <a:ext cx="2670048" cy="914400"/>
+            <a:off x="411480" y="4261104"/>
+            <a:ext cx="2761488" cy="1005840"/>
           </a:xfrm>
           <a:prstGeom prst="rect">
             <a:avLst/>
@@ -5124,7 +5124,7 @@
           <a:p>
             <a:pPr algn="l"/>
             <a:r>
-              <a:rPr sz="1500" b="0">
+              <a:rPr sz="1550" b="0">
                 <a:solidFill>
                   <a:srgbClr val="4A4540"/>
                 </a:solidFill>
@@ -5143,8 +5143,8 @@
         </p:nvSpPr>
         <p:spPr>
           <a:xfrm>
-            <a:off x="3300984" y="1664208"/>
-            <a:ext cx="2670048" cy="274320"/>
+            <a:off x="3291840" y="1664208"/>
+            <a:ext cx="2761488" cy="274320"/>
           </a:xfrm>
           <a:prstGeom prst="rect">
             <a:avLst/>
@@ -5186,8 +5186,8 @@
         </p:blipFill>
         <p:spPr>
           <a:xfrm>
-            <a:off x="3300984" y="2011680"/>
-            <a:ext cx="2670048" cy="2021608"/>
+            <a:off x="3291840" y="2048256"/>
+            <a:ext cx="2761488" cy="2090841"/>
           </a:xfrm>
           <a:prstGeom prst="rect">
             <a:avLst/>
@@ -5202,8 +5202,8 @@
         </p:nvSpPr>
         <p:spPr>
           <a:xfrm>
-            <a:off x="3300984" y="4078224"/>
-            <a:ext cx="2670048" cy="914400"/>
+            <a:off x="3291840" y="4261104"/>
+            <a:ext cx="2761488" cy="1005840"/>
           </a:xfrm>
           <a:prstGeom prst="rect">
             <a:avLst/>
@@ -5218,7 +5218,7 @@
           <a:p>
             <a:pPr algn="l"/>
             <a:r>
-              <a:rPr sz="1500" b="0">
+              <a:rPr sz="1550" b="0">
                 <a:solidFill>
                   <a:srgbClr val="4A4540"/>
                 </a:solidFill>
@@ -5237,8 +5237,8 @@
         </p:nvSpPr>
         <p:spPr>
           <a:xfrm>
-            <a:off x="6126479" y="1664208"/>
-            <a:ext cx="2670048" cy="274320"/>
+            <a:off x="6172200" y="1664208"/>
+            <a:ext cx="2761488" cy="274320"/>
           </a:xfrm>
           <a:prstGeom prst="rect">
             <a:avLst/>
@@ -5280,8 +5280,8 @@
         </p:blipFill>
         <p:spPr>
           <a:xfrm>
-            <a:off x="6126479" y="2011680"/>
-            <a:ext cx="2670048" cy="2021608"/>
+            <a:off x="6172200" y="2048256"/>
+            <a:ext cx="2761488" cy="2090841"/>
           </a:xfrm>
           <a:prstGeom prst="rect">
             <a:avLst/>
@@ -5296,8 +5296,8 @@
         </p:nvSpPr>
         <p:spPr>
           <a:xfrm>
-            <a:off x="6126479" y="4078224"/>
-            <a:ext cx="2670048" cy="914400"/>
+            <a:off x="6172200" y="4261104"/>
+            <a:ext cx="2761488" cy="1005840"/>
           </a:xfrm>
           <a:prstGeom prst="rect">
             <a:avLst/>
@@ -5312,7 +5312,7 @@
           <a:p>
             <a:pPr algn="l"/>
             <a:r>
-              <a:rPr sz="1500" b="0">
+              <a:rPr sz="1550" b="0">
                 <a:solidFill>
                   <a:srgbClr val="4A4540"/>
                 </a:solidFill>
@@ -5331,8 +5331,8 @@
         </p:nvSpPr>
         <p:spPr>
           <a:xfrm>
-            <a:off x="8951976" y="1664208"/>
-            <a:ext cx="2670048" cy="274320"/>
+            <a:off x="9052559" y="1664208"/>
+            <a:ext cx="2761488" cy="274320"/>
           </a:xfrm>
           <a:prstGeom prst="rect">
             <a:avLst/>
@@ -5374,8 +5374,8 @@
         </p:blipFill>
         <p:spPr>
           <a:xfrm>
-            <a:off x="8951976" y="2011680"/>
-            <a:ext cx="2670048" cy="2021608"/>
+            <a:off x="9052559" y="2048256"/>
+            <a:ext cx="2761488" cy="2090841"/>
           </a:xfrm>
           <a:prstGeom prst="rect">
             <a:avLst/>
@@ -5390,8 +5390,8 @@
         </p:nvSpPr>
         <p:spPr>
           <a:xfrm>
-            <a:off x="8951976" y="4078224"/>
-            <a:ext cx="2670048" cy="914400"/>
+            <a:off x="9052559" y="4261104"/>
+            <a:ext cx="2761488" cy="1005840"/>
           </a:xfrm>
           <a:prstGeom prst="rect">
             <a:avLst/>
@@ -5406,7 +5406,7 @@
           <a:p>
             <a:pPr algn="l"/>
             <a:r>
-              <a:rPr sz="1500" b="0">
+              <a:rPr sz="1550" b="0">
                 <a:solidFill>
                   <a:srgbClr val="4A4540"/>
                 </a:solidFill>
@@ -5419,121 +5419,7 @@
       </p:sp>
       <p:sp>
         <p:nvSpPr>
-          <p:cNvPr id="18" name="Rectangle 17"/>
-          <p:cNvSpPr/>
-          <p:nvPr/>
-        </p:nvSpPr>
-        <p:spPr>
-          <a:xfrm>
-            <a:off x="475488" y="5102352"/>
-            <a:ext cx="11256264" cy="1024128"/>
-          </a:xfrm>
-          <a:prstGeom prst="rect">
-            <a:avLst/>
-          </a:prstGeom>
-          <a:solidFill>
-            <a:srgbClr val="F7F4EF"/>
-          </a:solidFill>
-          <a:ln>
-            <a:noFill/>
-          </a:ln>
-          <a:effectLst/>
-        </p:spPr>
-        <p:style>
-          <a:lnRef idx="1">
-            <a:schemeClr val="accent1"/>
-          </a:lnRef>
-          <a:fillRef idx="3">
-            <a:schemeClr val="accent1"/>
-          </a:fillRef>
-          <a:effectRef idx="2">
-            <a:schemeClr val="accent1"/>
-          </a:effectRef>
-          <a:fontRef idx="minor">
-            <a:schemeClr val="lt1"/>
-          </a:fontRef>
-        </p:style>
-        <p:txBody>
-          <a:bodyPr rtlCol="0" anchor="ctr"/>
-          <a:lstStyle/>
-          <a:p>
-            <a:pPr algn="ctr"/>
-          </a:p>
-        </p:txBody>
-      </p:sp>
-      <p:sp>
-        <p:nvSpPr>
-          <p:cNvPr id="19" name="TextBox 18"/>
-          <p:cNvSpPr txBox="1"/>
-          <p:nvPr/>
-        </p:nvSpPr>
-        <p:spPr>
-          <a:xfrm>
-            <a:off x="749808" y="5193792"/>
-            <a:ext cx="10789920" cy="329184"/>
-          </a:xfrm>
-          <a:prstGeom prst="rect">
-            <a:avLst/>
-          </a:prstGeom>
-          <a:noFill/>
-        </p:spPr>
-        <p:txBody>
-          <a:bodyPr wrap="square" anchor="t" lIns="0" rIns="0" tIns="0" bIns="0">
-            <a:spAutoFit/>
-          </a:bodyPr>
-          <a:lstStyle/>
-          <a:p>
-            <a:pPr algn="l"/>
-            <a:r>
-              <a:rPr sz="1800" b="1">
-                <a:solidFill>
-                  <a:srgbClr val="23201C"/>
-                </a:solidFill>
-                <a:latin typeface="Cambria"/>
-              </a:rPr>
-              <a:t>All four fit the drive test. Only one still works off it.</a:t>
-            </a:r>
-          </a:p>
-        </p:txBody>
-      </p:sp>
-      <p:sp>
-        <p:nvSpPr>
-          <p:cNvPr id="20" name="TextBox 19"/>
-          <p:cNvSpPr txBox="1"/>
-          <p:nvPr/>
-        </p:nvSpPr>
-        <p:spPr>
-          <a:xfrm>
-            <a:off x="749808" y="5559552"/>
-            <a:ext cx="10789920" cy="512064"/>
-          </a:xfrm>
-          <a:prstGeom prst="rect">
-            <a:avLst/>
-          </a:prstGeom>
-          <a:noFill/>
-        </p:spPr>
-        <p:txBody>
-          <a:bodyPr wrap="square" anchor="t" lIns="0" rIns="0" tIns="0" bIns="0">
-            <a:spAutoFit/>
-          </a:bodyPr>
-          <a:lstStyle/>
-          <a:p>
-            <a:pPr algn="l"/>
-            <a:r>
-              <a:rPr sz="1500" b="0">
-                <a:solidFill>
-                  <a:srgbClr val="4A4540"/>
-                </a:solidFill>
-                <a:latin typeface="Calibri"/>
-              </a:rPr>
-              <a:t>Every one of them lands within about 8 dB of the measurements. Score them on ground they were never shown and three of the four fall apart.</a:t>
-            </a:r>
-          </a:p>
-        </p:txBody>
-      </p:sp>
-      <p:sp>
-        <p:nvSpPr>
-          <p:cNvPr id="21" name="TextBox 20"/>
+          <p:cNvPr id="18" name="TextBox 17"/>
           <p:cNvSpPr txBox="1"/>
           <p:nvPr/>
         </p:nvSpPr>

</xml_diff>

<commit_message>
Put the needs row into words that need no explaining
'distance and bearing' is the model's vocabulary, not an audience's. Bearing is
the compass direction from the tower, and it matters here because the site is
three-sectored -- a receiver 5 km north and one 5 km south-west see different
signal at the same distance. That is worth saying out loud and not worth making
anyone decode off a slide.

  how far, and which way
  a 3-D model of the ground
  thousands of measurements
  measurements, and a law

The row now wraps to two lines, which it needed at this width anyway.

Co-Authored-By: Claude Opus 5 <noreply@anthropic.com>
</commit_message>
<xml_diff>
--- a/ARA_Challenge3.pptx
+++ b/ARA_Challenge3.pptx
@@ -5187,8 +5187,8 @@
         </p:nvSpPr>
         <p:spPr>
           <a:xfrm>
-            <a:off x="411480" y="5477256"/>
-            <a:ext cx="2761488" cy="310896"/>
+            <a:off x="411480" y="5458968"/>
+            <a:ext cx="2761488" cy="512064"/>
           </a:xfrm>
           <a:prstGeom prst="rect">
             <a:avLst/>
@@ -5209,7 +5209,7 @@
                 </a:solidFill>
                 <a:latin typeface="Calibri"/>
               </a:rPr>
-              <a:t>needs: distance and bearing</a:t>
+              <a:t>needs: how far, and which way</a:t>
             </a:r>
           </a:p>
         </p:txBody>
@@ -5360,8 +5360,8 @@
         </p:nvSpPr>
         <p:spPr>
           <a:xfrm>
-            <a:off x="3291840" y="5477256"/>
-            <a:ext cx="2761488" cy="310896"/>
+            <a:off x="3291840" y="5458968"/>
+            <a:ext cx="2761488" cy="512064"/>
           </a:xfrm>
           <a:prstGeom prst="rect">
             <a:avLst/>
@@ -5382,7 +5382,7 @@
                 </a:solidFill>
                 <a:latin typeface="Calibri"/>
               </a:rPr>
-              <a:t>needs: a 3-D scene</a:t>
+              <a:t>needs: a 3-D model of the ground</a:t>
             </a:r>
           </a:p>
         </p:txBody>
@@ -5533,8 +5533,8 @@
         </p:nvSpPr>
         <p:spPr>
           <a:xfrm>
-            <a:off x="6172200" y="5477256"/>
-            <a:ext cx="2761488" cy="310896"/>
+            <a:off x="6172200" y="5458968"/>
+            <a:ext cx="2761488" cy="512064"/>
           </a:xfrm>
           <a:prstGeom prst="rect">
             <a:avLst/>
@@ -5555,7 +5555,7 @@
                 </a:solidFill>
                 <a:latin typeface="Calibri"/>
               </a:rPr>
-              <a:t>needs: thousands of examples</a:t>
+              <a:t>needs: thousands of measurements</a:t>
             </a:r>
           </a:p>
         </p:txBody>
@@ -5706,8 +5706,8 @@
         </p:nvSpPr>
         <p:spPr>
           <a:xfrm>
-            <a:off x="9052559" y="5477256"/>
-            <a:ext cx="2761488" cy="310896"/>
+            <a:off x="9052559" y="5458968"/>
+            <a:ext cx="2761488" cy="512064"/>
           </a:xfrm>
           <a:prstGeom prst="rect">
             <a:avLst/>
@@ -5728,7 +5728,7 @@
                 </a:solidFill>
                 <a:latin typeface="Calibri"/>
               </a:rPr>
-              <a:t>needs: examples and a law</a:t>
+              <a:t>needs: measurements, and a law</a:t>
             </a:r>
           </a:p>
         </p:txBody>

</xml_diff>